<commit_message>
Update ensemble notebook and report
</commit_message>
<xml_diff>
--- a/04_reports/Forecasting_Approach_01.pptx
+++ b/04_reports/Forecasting_Approach_01.pptx
@@ -198,7 +198,7 @@
           <a:p>
             <a:fld id="{2BF0393C-EE02-9F45-9A2B-7F4AFF6DAEEC}" type="datetimeFigureOut">
               <a:rPr lang="en-NL" smtClean="0"/>
-              <a:t>25/04/2025</a:t>
+              <a:t>08/05/2025</a:t>
             </a:fld>
             <a:endParaRPr lang="en-NL"/>
           </a:p>
@@ -615,7 +615,7 @@
           <a:p>
             <a:fld id="{1E6A08FF-52C1-AC4B-874F-8C509BB53652}" type="datetimeFigureOut">
               <a:rPr lang="en-NL" smtClean="0"/>
-              <a:t>25/04/2025</a:t>
+              <a:t>08/05/2025</a:t>
             </a:fld>
             <a:endParaRPr lang="en-NL"/>
           </a:p>
@@ -815,7 +815,7 @@
           <a:p>
             <a:fld id="{1E6A08FF-52C1-AC4B-874F-8C509BB53652}" type="datetimeFigureOut">
               <a:rPr lang="en-NL" smtClean="0"/>
-              <a:t>25/04/2025</a:t>
+              <a:t>08/05/2025</a:t>
             </a:fld>
             <a:endParaRPr lang="en-NL"/>
           </a:p>
@@ -1025,7 +1025,7 @@
           <a:p>
             <a:fld id="{1E6A08FF-52C1-AC4B-874F-8C509BB53652}" type="datetimeFigureOut">
               <a:rPr lang="en-NL" smtClean="0"/>
-              <a:t>25/04/2025</a:t>
+              <a:t>08/05/2025</a:t>
             </a:fld>
             <a:endParaRPr lang="en-NL"/>
           </a:p>
@@ -1225,7 +1225,7 @@
           <a:p>
             <a:fld id="{1E6A08FF-52C1-AC4B-874F-8C509BB53652}" type="datetimeFigureOut">
               <a:rPr lang="en-NL" smtClean="0"/>
-              <a:t>25/04/2025</a:t>
+              <a:t>08/05/2025</a:t>
             </a:fld>
             <a:endParaRPr lang="en-NL"/>
           </a:p>
@@ -1501,7 +1501,7 @@
           <a:p>
             <a:fld id="{1E6A08FF-52C1-AC4B-874F-8C509BB53652}" type="datetimeFigureOut">
               <a:rPr lang="en-NL" smtClean="0"/>
-              <a:t>25/04/2025</a:t>
+              <a:t>08/05/2025</a:t>
             </a:fld>
             <a:endParaRPr lang="en-NL"/>
           </a:p>
@@ -1769,7 +1769,7 @@
           <a:p>
             <a:fld id="{1E6A08FF-52C1-AC4B-874F-8C509BB53652}" type="datetimeFigureOut">
               <a:rPr lang="en-NL" smtClean="0"/>
-              <a:t>25/04/2025</a:t>
+              <a:t>08/05/2025</a:t>
             </a:fld>
             <a:endParaRPr lang="en-NL"/>
           </a:p>
@@ -2184,7 +2184,7 @@
           <a:p>
             <a:fld id="{1E6A08FF-52C1-AC4B-874F-8C509BB53652}" type="datetimeFigureOut">
               <a:rPr lang="en-NL" smtClean="0"/>
-              <a:t>25/04/2025</a:t>
+              <a:t>08/05/2025</a:t>
             </a:fld>
             <a:endParaRPr lang="en-NL"/>
           </a:p>
@@ -2326,7 +2326,7 @@
           <a:p>
             <a:fld id="{1E6A08FF-52C1-AC4B-874F-8C509BB53652}" type="datetimeFigureOut">
               <a:rPr lang="en-NL" smtClean="0"/>
-              <a:t>25/04/2025</a:t>
+              <a:t>08/05/2025</a:t>
             </a:fld>
             <a:endParaRPr lang="en-NL"/>
           </a:p>
@@ -2439,7 +2439,7 @@
           <a:p>
             <a:fld id="{1E6A08FF-52C1-AC4B-874F-8C509BB53652}" type="datetimeFigureOut">
               <a:rPr lang="en-NL" smtClean="0"/>
-              <a:t>25/04/2025</a:t>
+              <a:t>08/05/2025</a:t>
             </a:fld>
             <a:endParaRPr lang="en-NL"/>
           </a:p>
@@ -2752,7 +2752,7 @@
           <a:p>
             <a:fld id="{1E6A08FF-52C1-AC4B-874F-8C509BB53652}" type="datetimeFigureOut">
               <a:rPr lang="en-NL" smtClean="0"/>
-              <a:t>25/04/2025</a:t>
+              <a:t>08/05/2025</a:t>
             </a:fld>
             <a:endParaRPr lang="en-NL"/>
           </a:p>
@@ -3041,7 +3041,7 @@
           <a:p>
             <a:fld id="{1E6A08FF-52C1-AC4B-874F-8C509BB53652}" type="datetimeFigureOut">
               <a:rPr lang="en-NL" smtClean="0"/>
-              <a:t>25/04/2025</a:t>
+              <a:t>08/05/2025</a:t>
             </a:fld>
             <a:endParaRPr lang="en-NL"/>
           </a:p>
@@ -3284,7 +3284,7 @@
           <a:p>
             <a:fld id="{1E6A08FF-52C1-AC4B-874F-8C509BB53652}" type="datetimeFigureOut">
               <a:rPr lang="en-NL" smtClean="0"/>
-              <a:t>25/04/2025</a:t>
+              <a:t>08/05/2025</a:t>
             </a:fld>
             <a:endParaRPr lang="en-NL"/>
           </a:p>

</xml_diff>